<commit_message>
fix: remove fake hashes, real office names and endorsement wording
- Certificate page, instrument page and PDF no longer show a
  hand-typed SHA-256 value; they show the ECDSA signature instead
- Demo accounts, applicants and issuing authority use clearly fictional
  demo offices and obviously fake phone numbers
- Migration replaces the old values in the live database without
  touching any signed certificate field
- "Open-source" claims say "no licence fee, source code is public"
  until a licence is chosen
- Assistant no longer calls itself official; applications heading plain
- Theme sweep: stray blue and purple classes mapped to the ink palette

Co-Authored-By: Claude Opus 5.5 <noreply@anthropic.com>
</commit_message>
<xml_diff>
--- a/sih-submission/08-final-2026-09-30/TULA_SIH2026_FriendlyFire_v7.pptx
+++ b/sih-submission/08-final-2026-09-30/TULA_SIH2026_FriendlyFire_v7.pptx
@@ -872,7 +872,7 @@
           <a:lstStyle/>
           <a:p>
             <a:r>
-              <a:t>Table is honest: tick = works on the live site now, half = wired but needs a provider key. Before the final build we test with 5 LMOs and 1 GATC in one district and only proceed if the usability score is at least 70. Viability: the customer is the government; traders and citizens never pay. Running cost is small (pay-per-use cloud, open source) and fits in the service charge States already collect. Funding path: SIH award and incubation, then Startup India Seed Fund or MeitY Startup Hub, then State e-governance budgets.</a:t>
+              <a:t>Table is honest: tick = works on the live site now, half = wired but needs a provider key. Before the final build we test with 5 LMOs and 1 GATC in one district and only proceed if the usability score is at least 70. Viability: the customer is the government; traders and citizens never pay. Running cost is small (pay-per-use cloud, no licence fee) and fits in the service charge States already collect. Funding path: SIH award and incubation, then Startup India Seed Fund or MeitY Startup Hub, then State e-governance budgets.</a:t>
             </a:r>
           </a:p>
         </p:txBody>
@@ -14749,7 +14749,7 @@
                 </a:solidFill>
                 <a:latin typeface="Calibri"/>
               </a:rPr>
-              <a:t>Open-source, pay-per-use cloud, no licence fees. Running cost fits in the service charge States already add to verification fees. No lock-in: standard Postgres, can move to State cloud.</a:t>
+              <a:t>No licence fee, pay-per-use cloud. Running cost fits in the service charge States already add to verification fees. No lock-in: public source code, standard Postgres, can move to State cloud.</a:t>
             </a:r>
           </a:p>
         </p:txBody>

</xml_diff>